<commit_message>
feat: updated demo materials
</commit_message>
<xml_diff>
--- a/docs/presentation/FYP-demo.pptx
+++ b/docs/presentation/FYP-demo.pptx
@@ -884,7 +884,7 @@
           <a:p>
             <a:r>
               <a:rPr lang="en-US" dirty="0"/>
-              <a:t>[1:11]  ~196 words  ★
+              <a:t>[1:11]  ~226 words  ★
 This is the centre of the project — one turn, left to right.
 Your answer arrives at the chat endpoint. Before anything is generated, a
 second model call scores it against the rubric for that round type, at low
@@ -895,6 +895,9 @@
 difficulty target. Those become a private steering block inside the
 interviewer's prompt, which the candidate never sees. Then the next question
 streams back.
+Why that order? A verdict that only arrives at the end of the interview cannot
+change the interview. Scoring before generating is what makes the questioning
+adaptive rather than scripted.
 Three engineering points. Scoring is bounded at four seconds — I measured the
 turn before changing it, rather than guessing. Past that deadline the question
 starts unsteered, but the verdict is still collected and stored, so the
@@ -992,7 +995,7 @@
           <a:p>
             <a:r>
               <a:rPr lang="en-US" dirty="0"/>
-              <a:t>[2:29]  ~205 words  ★
+              <a:t>[2:41]  ~205 words  ★
 This is the claim I can prove, and the one I'd most like you to look at.
 The persona reaches the model down two paths. Textually, each dial becomes a
 sentence in the system prompt — and prompt text has no effect you can compute,
@@ -1099,7 +1102,7 @@
           <a:p>
             <a:r>
               <a:rPr lang="en-US" dirty="0"/>
-              <a:t>[3:51]  ~215 words  ★
+              <a:t>[4:03]  ~215 words  ★
 Second — I don't estimate what this costs. I measure it.
 Every OpenAI call records its token usage, including how much was served from
 cache, into a Postgres table as the call happens. A command-line tool reads
@@ -1205,7 +1208,7 @@
           <a:p>
             <a:r>
               <a:rPr lang="en-US" dirty="0"/>
-              <a:t>[5:17]  ~166 words
+              <a:t>[5:29]  ~202 words
 Finally, where it honestly stands.
 Built and verified: 299 unit tests across 31 files, all passing in CI on every
 push alongside typecheck and lint. Ten migrations with row-level security on
@@ -1213,9 +1216,11 @@
 inherits the same access rules as everything else.
 Built but not yet measured, and I'll be direct. I wrote an evaluation harness
 for scoring accuracy, with eighteen hand-authored fixtures and defined
-metrics. The results aren't collected yet. Same for user acceptance testing:
-the plan, the handout and the exit criteria are written; no participants have
-been through it.
+metrics. The results aren't collected yet — not because the harness doesn't
+work, but because every run is billed, and I wanted the metrics and the
+fixture set settled first so the first run is the real one rather than a
+pilot. Same for user acceptance testing: the plan, the handout and the exit
+criteria are written; no participants have been through it.
 Some things are deliberately out of scope — submitted code is reviewed, never
 executed, and it's English only.
 The rule I held to throughout: never claim a number I haven't run. That's why
@@ -7021,10 +7026,30 @@
           <a:lstStyle/>
           <a:p>
             <a:pPr indent="0" marL="0">
-              <a:buNone/>
-            </a:pPr>
-            <a:r>
-              <a:rPr lang="en-US" sz="1700" b="1" dirty="0">
+              <a:lnSpc>
+                <a:spcPts val="1800"/>
+              </a:lnSpc>
+              <a:buNone/>
+            </a:pPr>
+            <a:r>
+              <a:rPr lang="en-US" sz="1300" b="1" dirty="0">
+                <a:solidFill>
+                  <a:srgbClr val="1D4ED8"/>
+                </a:solidFill>
+                <a:latin typeface="Arial" pitchFamily="34" charset="0"/>
+                <a:ea typeface="Arial" pitchFamily="34" charset="-122"/>
+                <a:cs typeface="Arial" pitchFamily="34" charset="-120"/>
+              </a:rPr>
+              <a:t>Why score before generating?  </a:t>
+            </a:r>
+            <a:pPr indent="0" marL="0">
+              <a:lnSpc>
+                <a:spcPts val="1800"/>
+              </a:lnSpc>
+              <a:buNone/>
+            </a:pPr>
+            <a:r>
+              <a:rPr lang="en-US" sz="1300" dirty="0">
                 <a:solidFill>
                   <a:srgbClr val="14161A"/>
                 </a:solidFill>
@@ -7032,9 +7057,9 @@
                 <a:ea typeface="Arial" pitchFamily="34" charset="-122"/>
                 <a:cs typeface="Arial" pitchFamily="34" charset="-120"/>
               </a:rPr>
-              <a:t>The score is not just reported at the end. It is an input to the next question.</a:t>
-            </a:r>
-            <a:endParaRPr lang="en-US" sz="1700" dirty="0"/>
+              <a:t>A verdict that only arrives at the end of the interview cannot change the interview. Scoring first is what makes the questioning adaptive rather than scripted — and bounding it at 4 s is what stops that costing a stalled reply.</a:t>
+            </a:r>
+            <a:endParaRPr lang="en-US" sz="1300" dirty="0"/>
           </a:p>
         </p:txBody>
       </p:sp>
@@ -8079,7 +8104,41 @@
                 <a:ea typeface="Arial" pitchFamily="34" charset="-122"/>
                 <a:cs typeface="Arial" pitchFamily="34" charset="-120"/>
               </a:rPr>
-              <a:t>the dials are coarse — strictness 1→10 moves difficulty only 5→7, and 5/6/7 emit byte-identical prompts. Scoring is persona-blind by design: a strict interviewer and a warm one grade the same answer identically.</a:t>
+              <a:t>the dials are coarse — strictness 1→10 moves difficulty only 5→7, and 5/6/7 emit byte-identical prompts. Scoring is persona-blind </a:t>
+            </a:r>
+            <a:pPr indent="0" marL="0">
+              <a:lnSpc>
+                <a:spcPts val="1450"/>
+              </a:lnSpc>
+              <a:buNone/>
+            </a:pPr>
+            <a:r>
+              <a:rPr lang="en-US" sz="1050" i="1" dirty="0">
+                <a:solidFill>
+                  <a:srgbClr val="3F4750"/>
+                </a:solidFill>
+                <a:latin typeface="Arial" pitchFamily="34" charset="0"/>
+                <a:ea typeface="Arial" pitchFamily="34" charset="-122"/>
+                <a:cs typeface="Arial" pitchFamily="34" charset="-120"/>
+              </a:rPr>
+              <a:t>by design</a:t>
+            </a:r>
+            <a:pPr indent="0" marL="0">
+              <a:lnSpc>
+                <a:spcPts val="1450"/>
+              </a:lnSpc>
+              <a:buNone/>
+            </a:pPr>
+            <a:r>
+              <a:rPr lang="en-US" sz="1050" dirty="0">
+                <a:solidFill>
+                  <a:srgbClr val="3F4750"/>
+                </a:solidFill>
+                <a:latin typeface="Arial" pitchFamily="34" charset="0"/>
+                <a:ea typeface="Arial" pitchFamily="34" charset="-122"/>
+                <a:cs typeface="Arial" pitchFamily="34" charset="-120"/>
+              </a:rPr>
+              <a:t>: a strict interviewer and a warm one grade the same answer identically, because grading should not depend on who asked. Persona changes what gets asked next, never what an answer was worth.</a:t>
             </a:r>
             <a:endParaRPr lang="en-US" sz="1050" dirty="0"/>
           </a:p>
@@ -8943,7 +9002,7 @@
                 <a:ea typeface="Arial" pitchFamily="34" charset="-122"/>
                 <a:cs typeface="Arial" pitchFamily="34" charset="-120"/>
               </a:rPr>
-              <a:t> engage. On a bare session the stable prefix is about 590 tokens — under the floor — so it does not fire at all. The tool reports that in words rather than printing a zero for me to spin.</a:t>
+              <a:t> engage. On a bare session the stable prefix is about 590 tokens — under the floor — so it does not fire at all. The tool reports that in words, rather than printing a zero for me to reinterpret.</a:t>
             </a:r>
             <a:endParaRPr lang="en-US" sz="1250" dirty="0"/>
           </a:p>
@@ -9496,7 +9555,7 @@
         <p:spPr>
           <a:xfrm>
             <a:off x="822960" y="2029968"/>
-            <a:ext cx="3058058" cy="1865376"/>
+            <a:ext cx="3058058" cy="1463040"/>
           </a:xfrm>
           <a:prstGeom prst="rect">
             <a:avLst/>
@@ -9647,7 +9706,49 @@
       </p:sp>
       <p:sp>
         <p:nvSpPr>
-          <p:cNvPr id="9" name="Shape 7"/>
+          <p:cNvPr id="9" name="Text 7"/>
+          <p:cNvSpPr/>
+          <p:nvPr/>
+        </p:nvSpPr>
+        <p:spPr>
+          <a:xfrm>
+            <a:off x="822960" y="3529584"/>
+            <a:ext cx="3058058" cy="384048"/>
+          </a:xfrm>
+          <a:prstGeom prst="rect">
+            <a:avLst/>
+          </a:prstGeom>
+          <a:noFill/>
+          <a:ln/>
+        </p:spPr>
+        <p:txBody>
+          <a:bodyPr wrap="square" rtlCol="0" anchor="t"/>
+          <a:lstStyle/>
+          <a:p>
+            <a:pPr indent="0" marL="0">
+              <a:lnSpc>
+                <a:spcPts val="1300"/>
+              </a:lnSpc>
+              <a:buNone/>
+            </a:pPr>
+            <a:r>
+              <a:rPr lang="en-US" sz="950" i="1" dirty="0">
+                <a:solidFill>
+                  <a:srgbClr val="15803D"/>
+                </a:solidFill>
+                <a:latin typeface="Arial" pitchFamily="34" charset="0"/>
+                <a:ea typeface="Arial" pitchFamily="34" charset="-122"/>
+                <a:cs typeface="Arial" pitchFamily="34" charset="-120"/>
+              </a:rPr>
+              <a:t>“Verified” means a command you can run, or a test that fails when the claim stops being true.</a:t>
+            </a:r>
+            <a:endParaRPr lang="en-US" sz="950" dirty="0"/>
+          </a:p>
+        </p:txBody>
+      </p:sp>
+      <p:sp>
+        <p:nvSpPr>
+          <p:cNvPr id="10" name="Shape 8"/>
           <p:cNvSpPr/>
           <p:nvPr/>
         </p:nvSpPr>
@@ -9672,7 +9773,7 @@
       </p:sp>
       <p:sp>
         <p:nvSpPr>
-          <p:cNvPr id="10" name="Shape 8"/>
+          <p:cNvPr id="11" name="Shape 9"/>
           <p:cNvSpPr/>
           <p:nvPr/>
         </p:nvSpPr>
@@ -9697,7 +9798,7 @@
       </p:sp>
       <p:sp>
         <p:nvSpPr>
-          <p:cNvPr id="11" name="Text 9"/>
+          <p:cNvPr id="12" name="Text 10"/>
           <p:cNvSpPr/>
           <p:nvPr/>
         </p:nvSpPr>
@@ -9736,14 +9837,14 @@
       </p:sp>
       <p:sp>
         <p:nvSpPr>
-          <p:cNvPr id="12" name="Text 10"/>
+          <p:cNvPr id="13" name="Text 11"/>
           <p:cNvSpPr/>
           <p:nvPr/>
         </p:nvSpPr>
         <p:spPr>
           <a:xfrm>
             <a:off x="4612538" y="2029968"/>
-            <a:ext cx="3058058" cy="1865376"/>
+            <a:ext cx="3058058" cy="1463040"/>
           </a:xfrm>
           <a:prstGeom prst="rect">
             <a:avLst/>
@@ -9836,7 +9937,49 @@
       </p:sp>
       <p:sp>
         <p:nvSpPr>
-          <p:cNvPr id="13" name="Shape 11"/>
+          <p:cNvPr id="14" name="Text 12"/>
+          <p:cNvSpPr/>
+          <p:nvPr/>
+        </p:nvSpPr>
+        <p:spPr>
+          <a:xfrm>
+            <a:off x="4612538" y="3529584"/>
+            <a:ext cx="3058058" cy="384048"/>
+          </a:xfrm>
+          <a:prstGeom prst="rect">
+            <a:avLst/>
+          </a:prstGeom>
+          <a:noFill/>
+          <a:ln/>
+        </p:spPr>
+        <p:txBody>
+          <a:bodyPr wrap="square" rtlCol="0" anchor="t"/>
+          <a:lstStyle/>
+          <a:p>
+            <a:pPr indent="0" marL="0">
+              <a:lnSpc>
+                <a:spcPts val="1300"/>
+              </a:lnSpc>
+              <a:buNone/>
+            </a:pPr>
+            <a:r>
+              <a:rPr lang="en-US" sz="950" i="1" dirty="0">
+                <a:solidFill>
+                  <a:srgbClr val="9A5B08"/>
+                </a:solidFill>
+                <a:latin typeface="Arial" pitchFamily="34" charset="0"/>
+                <a:ea typeface="Arial" pitchFamily="34" charset="-122"/>
+                <a:cs typeface="Arial" pitchFamily="34" charset="-120"/>
+              </a:rPr>
+              <a:t>Every run is billed, so I settled the metrics and fixtures first — the first run is the real one, not a pilot.</a:t>
+            </a:r>
+            <a:endParaRPr lang="en-US" sz="950" dirty="0"/>
+          </a:p>
+        </p:txBody>
+      </p:sp>
+      <p:sp>
+        <p:nvSpPr>
+          <p:cNvPr id="15" name="Shape 13"/>
           <p:cNvSpPr/>
           <p:nvPr/>
         </p:nvSpPr>
@@ -9861,7 +10004,7 @@
       </p:sp>
       <p:sp>
         <p:nvSpPr>
-          <p:cNvPr id="14" name="Shape 12"/>
+          <p:cNvPr id="16" name="Shape 14"/>
           <p:cNvSpPr/>
           <p:nvPr/>
         </p:nvSpPr>
@@ -9886,7 +10029,7 @@
       </p:sp>
       <p:sp>
         <p:nvSpPr>
-          <p:cNvPr id="15" name="Text 13"/>
+          <p:cNvPr id="17" name="Text 15"/>
           <p:cNvSpPr/>
           <p:nvPr/>
         </p:nvSpPr>
@@ -9925,14 +10068,14 @@
       </p:sp>
       <p:sp>
         <p:nvSpPr>
-          <p:cNvPr id="16" name="Text 14"/>
+          <p:cNvPr id="18" name="Text 16"/>
           <p:cNvSpPr/>
           <p:nvPr/>
         </p:nvSpPr>
         <p:spPr>
           <a:xfrm>
             <a:off x="8402117" y="2029968"/>
-            <a:ext cx="3058058" cy="1865376"/>
+            <a:ext cx="3058058" cy="1463040"/>
           </a:xfrm>
           <a:prstGeom prst="rect">
             <a:avLst/>
@@ -10054,7 +10197,49 @@
       </p:sp>
       <p:sp>
         <p:nvSpPr>
-          <p:cNvPr id="17" name="Shape 15"/>
+          <p:cNvPr id="19" name="Text 17"/>
+          <p:cNvSpPr/>
+          <p:nvPr/>
+        </p:nvSpPr>
+        <p:spPr>
+          <a:xfrm>
+            <a:off x="8402117" y="3529584"/>
+            <a:ext cx="3058058" cy="384048"/>
+          </a:xfrm>
+          <a:prstGeom prst="rect">
+            <a:avLst/>
+          </a:prstGeom>
+          <a:noFill/>
+          <a:ln/>
+        </p:spPr>
+        <p:txBody>
+          <a:bodyPr wrap="square" rtlCol="0" anchor="t"/>
+          <a:lstStyle/>
+          <a:p>
+            <a:pPr indent="0" marL="0">
+              <a:lnSpc>
+                <a:spcPts val="1300"/>
+              </a:lnSpc>
+              <a:buNone/>
+            </a:pPr>
+            <a:r>
+              <a:rPr lang="en-US" sz="950" i="1" dirty="0">
+                <a:solidFill>
+                  <a:srgbClr val="7A8593"/>
+                </a:solidFill>
+                <a:latin typeface="Arial" pitchFamily="34" charset="0"/>
+                <a:ea typeface="Arial" pitchFamily="34" charset="-122"/>
+                <a:cs typeface="Arial" pitchFamily="34" charset="-120"/>
+              </a:rPr>
+              <a:t>Each is a bounded, documented trade-off — recorded here rather than found by someone else.</a:t>
+            </a:r>
+            <a:endParaRPr lang="en-US" sz="950" dirty="0"/>
+          </a:p>
+        </p:txBody>
+      </p:sp>
+      <p:sp>
+        <p:nvSpPr>
+          <p:cNvPr id="20" name="Shape 18"/>
           <p:cNvSpPr/>
           <p:nvPr/>
         </p:nvSpPr>
@@ -10079,7 +10264,7 @@
       </p:sp>
       <p:sp>
         <p:nvSpPr>
-          <p:cNvPr id="18" name="Shape 16"/>
+          <p:cNvPr id="21" name="Shape 19"/>
           <p:cNvSpPr/>
           <p:nvPr/>
         </p:nvSpPr>
@@ -10104,7 +10289,7 @@
       </p:sp>
       <p:sp>
         <p:nvSpPr>
-          <p:cNvPr id="19" name="Text 17"/>
+          <p:cNvPr id="22" name="Text 20"/>
           <p:cNvSpPr/>
           <p:nvPr/>
         </p:nvSpPr>
@@ -10157,7 +10342,7 @@
       </p:sp>
       <p:sp>
         <p:nvSpPr>
-          <p:cNvPr id="20" name="Text 18"/>
+          <p:cNvPr id="23" name="Text 21"/>
           <p:cNvSpPr/>
           <p:nvPr/>
         </p:nvSpPr>
@@ -10196,7 +10381,7 @@
       </p:sp>
       <p:sp>
         <p:nvSpPr>
-          <p:cNvPr id="21" name="Shape 19"/>
+          <p:cNvPr id="24" name="Shape 22"/>
           <p:cNvSpPr/>
           <p:nvPr/>
         </p:nvSpPr>
@@ -10221,7 +10406,7 @@
       </p:sp>
       <p:sp>
         <p:nvSpPr>
-          <p:cNvPr id="22" name="Shape 20"/>
+          <p:cNvPr id="25" name="Shape 23"/>
           <p:cNvSpPr/>
           <p:nvPr/>
         </p:nvSpPr>
@@ -10246,7 +10431,7 @@
       </p:sp>
       <p:sp>
         <p:nvSpPr>
-          <p:cNvPr id="23" name="Text 21"/>
+          <p:cNvPr id="26" name="Text 24"/>
           <p:cNvSpPr/>
           <p:nvPr/>
         </p:nvSpPr>
@@ -10285,7 +10470,7 @@
       </p:sp>
       <p:sp>
         <p:nvSpPr>
-          <p:cNvPr id="24" name="Text 22"/>
+          <p:cNvPr id="27" name="Text 25"/>
           <p:cNvSpPr/>
           <p:nvPr/>
         </p:nvSpPr>
@@ -10324,7 +10509,7 @@
       </p:sp>
       <p:sp>
         <p:nvSpPr>
-          <p:cNvPr id="25" name="Text 23"/>
+          <p:cNvPr id="28" name="Text 26"/>
           <p:cNvSpPr/>
           <p:nvPr/>
         </p:nvSpPr>
@@ -10363,7 +10548,7 @@
       </p:sp>
       <p:sp>
         <p:nvSpPr>
-          <p:cNvPr id="26" name="Shape 24"/>
+          <p:cNvPr id="29" name="Shape 27"/>
           <p:cNvSpPr/>
           <p:nvPr/>
         </p:nvSpPr>
@@ -10388,7 +10573,7 @@
       </p:sp>
       <p:sp>
         <p:nvSpPr>
-          <p:cNvPr id="27" name="Shape 25"/>
+          <p:cNvPr id="30" name="Shape 28"/>
           <p:cNvSpPr/>
           <p:nvPr/>
         </p:nvSpPr>
@@ -10413,7 +10598,7 @@
       </p:sp>
       <p:sp>
         <p:nvSpPr>
-          <p:cNvPr id="28" name="Text 26"/>
+          <p:cNvPr id="31" name="Text 29"/>
           <p:cNvSpPr/>
           <p:nvPr/>
         </p:nvSpPr>
@@ -10452,7 +10637,7 @@
       </p:sp>
       <p:sp>
         <p:nvSpPr>
-          <p:cNvPr id="29" name="Text 27"/>
+          <p:cNvPr id="32" name="Text 30"/>
           <p:cNvSpPr/>
           <p:nvPr/>
         </p:nvSpPr>
@@ -10491,7 +10676,7 @@
       </p:sp>
       <p:sp>
         <p:nvSpPr>
-          <p:cNvPr id="30" name="Text 28"/>
+          <p:cNvPr id="33" name="Text 31"/>
           <p:cNvSpPr/>
           <p:nvPr/>
         </p:nvSpPr>
@@ -10530,7 +10715,7 @@
       </p:sp>
       <p:sp>
         <p:nvSpPr>
-          <p:cNvPr id="31" name="Shape 29"/>
+          <p:cNvPr id="34" name="Shape 32"/>
           <p:cNvSpPr/>
           <p:nvPr/>
         </p:nvSpPr>
@@ -10555,7 +10740,7 @@
       </p:sp>
       <p:sp>
         <p:nvSpPr>
-          <p:cNvPr id="32" name="Shape 30"/>
+          <p:cNvPr id="35" name="Shape 33"/>
           <p:cNvSpPr/>
           <p:nvPr/>
         </p:nvSpPr>
@@ -10580,7 +10765,7 @@
       </p:sp>
       <p:sp>
         <p:nvSpPr>
-          <p:cNvPr id="33" name="Text 31"/>
+          <p:cNvPr id="36" name="Text 34"/>
           <p:cNvSpPr/>
           <p:nvPr/>
         </p:nvSpPr>
@@ -10619,7 +10804,7 @@
       </p:sp>
       <p:sp>
         <p:nvSpPr>
-          <p:cNvPr id="34" name="Text 32"/>
+          <p:cNvPr id="37" name="Text 35"/>
           <p:cNvSpPr/>
           <p:nvPr/>
         </p:nvSpPr>
@@ -10658,7 +10843,7 @@
       </p:sp>
       <p:sp>
         <p:nvSpPr>
-          <p:cNvPr id="35" name="Text 33"/>
+          <p:cNvPr id="38" name="Text 36"/>
           <p:cNvSpPr/>
           <p:nvPr/>
         </p:nvSpPr>
@@ -10697,7 +10882,7 @@
       </p:sp>
       <p:sp>
         <p:nvSpPr>
-          <p:cNvPr id="37" name="Text 34"/>
+          <p:cNvPr id="40" name="Text 37"/>
           <p:cNvSpPr/>
           <p:nvPr/>
         </p:nvSpPr>
@@ -10736,7 +10921,7 @@
       </p:sp>
       <p:sp>
         <p:nvSpPr>
-          <p:cNvPr id="38" name="Text 35"/>
+          <p:cNvPr id="41" name="Text 38"/>
           <p:cNvSpPr/>
           <p:nvPr/>
         </p:nvSpPr>

</xml_diff>